<commit_message>
slide 5: report the asymmetric-loss result instead of calling it in progress
The slide still said "Now testing: Asymmetric Loss" and buried three
sub-bullets of statistical caveats that repeated slide 3. Both runs have
since finished, so the experiment now has an answer and the slide should
state it.

  - The four imbalance techniques stay, one line each, no parameter values
    on the slide.
  - The ASL result is now a small table rather than prose: focal 0.869 /
    0.748 vs asymmetric 0.834 / 0.758, outcome "clearly worse on DR - not
    used". Reporting the number the alternative actually scored is more
    convincing than describing what it was supposed to do.
  - Dropped the "why we cannot tune past 0.89" sub-bullets. That argument
    already lives on slide 3 and repeating it here made the slide dense
    without adding anything.

Six bullets down to four bullets plus a three-row table.

Co-Authored-By: Claude Opus 5 <noreply@anthropic.com>
</commit_message>
<xml_diff>
--- a/presentation/BRSET_ConvNeXtV2_Progress.pptx
+++ b/presentation/BRSET_ConvNeXtV2_Progress.pptx
@@ -6416,7 +6416,7 @@
               </a:defRPr>
             </a:pPr>
             <a:r>
-              <a:t>Four techniques, all aimed at stopping the healthy majority from drowning out the rare disease cases.</a:t>
+              <a:t>BRSET has about 15 healthy images for every diseased one. Four steps stop the majority drowning out the rest.</a:t>
             </a:r>
           </a:p>
         </p:txBody>
@@ -6429,8 +6429,8 @@
         </p:nvSpPr>
         <p:spPr>
           <a:xfrm>
-            <a:off x="685800" y="1828800"/>
-            <a:ext cx="10881360" cy="4206240"/>
+            <a:off x="685800" y="1965960"/>
+            <a:ext cx="10881360" cy="1965960"/>
           </a:xfrm>
           <a:prstGeom prst="rect">
             <a:avLst/>
@@ -6447,14 +6447,14 @@
               <a:spcAft>
                 <a:spcPts val="1000"/>
               </a:spcAft>
-              <a:defRPr sz="1600">
+              <a:defRPr sz="1700">
                 <a:solidFill>
                   <a:srgbClr val="1A1A1A"/>
                 </a:solidFill>
               </a:defRPr>
             </a:pPr>
             <a:r>
-              <a:t>• Focal loss — makes the model stop spending effort on the easy healthy images and concentrate on the hard ones. Strength set by one dial (γ = 2.0).</a:t>
+              <a:t>• Focal loss — the model stops spending effort on images it already gets right, and concentrates on the hard ones.</a:t>
             </a:r>
           </a:p>
           <a:p>
@@ -6462,14 +6462,14 @@
               <a:spcAft>
                 <a:spcPts val="1000"/>
               </a:spcAft>
-              <a:defRPr sz="1600">
+              <a:defRPr sz="1700">
                 <a:solidFill>
                   <a:srgbClr val="1A1A1A"/>
                 </a:solidFill>
               </a:defRPr>
             </a:pPr>
             <a:r>
-              <a:t>• Oversampling — during training, the rare diseased images are shown more often than they naturally occur.</a:t>
+              <a:t>• Oversampling — rare diseased images are shown more often during training than they naturally occur.</a:t>
             </a:r>
           </a:p>
           <a:p>
@@ -6477,14 +6477,14 @@
               <a:spcAft>
                 <a:spcPts val="1000"/>
               </a:spcAft>
-              <a:defRPr sz="1600">
+              <a:defRPr sz="1700">
                 <a:solidFill>
                   <a:srgbClr val="1A1A1A"/>
                 </a:solidFill>
               </a:defRPr>
             </a:pPr>
             <a:r>
-              <a:t>• Tuned decision cutoff — the referral threshold is chosen on validation data per finding, instead of a blind 0.5.</a:t>
+              <a:t>• Tuned referral cutoff — chosen on validation data, separately for each finding, instead of a blind 0.5.</a:t>
             </a:r>
           </a:p>
           <a:p>
@@ -6492,43 +6492,343 @@
               <a:spcAft>
                 <a:spcPts val="1000"/>
               </a:spcAft>
-              <a:defRPr sz="1600">
+              <a:defRPr sz="1700">
                 <a:solidFill>
                   <a:srgbClr val="1A1A1A"/>
                 </a:solidFill>
               </a:defRPr>
             </a:pPr>
             <a:r>
-              <a:t>• Now testing: Asymmetric Loss — the same idea, but with separate dials for healthy and diseased images, so rare positives are never discounted the way the abundant negatives are.</a:t>
-            </a:r>
-          </a:p>
-          <a:p>
-            <a:pPr>
-              <a:spcAft>
-                <a:spcPts val="1000"/>
-              </a:spcAft>
-              <a:defRPr sz="1600">
-                <a:solidFill>
-                  <a:srgbClr val="1A1A1A"/>
-                </a:solidFill>
-              </a:defRPr>
-            </a:pPr>
-            <a:r>
-              <a:t>• Also added: averaging the model over training, averaging predictions across flipped copies of each image, and choosing the cutoff robustly rather than from a single lucky value.</a:t>
-            </a:r>
-          </a:p>
-        </p:txBody>
-      </p:sp>
-      <p:sp>
-        <p:nvSpPr>
-          <p:cNvPr id="4" name="TextBox 3"/>
+              <a:t>• Averaging — the model is averaged over training, and each image is predicted from four flipped copies.</a:t>
+            </a:r>
+          </a:p>
+        </p:txBody>
+      </p:sp>
+      <p:graphicFrame>
+        <p:nvGraphicFramePr>
+          <p:cNvPr id="4" name="Table 3"/>
+          <p:cNvGraphicFramePr>
+            <a:graphicFrameLocks noGrp="1"/>
+          </p:cNvGraphicFramePr>
+          <p:nvPr/>
+        </p:nvGraphicFramePr>
+        <p:xfrm>
+          <a:off x="685800" y="4114800"/>
+          <a:ext cx="10058399" cy="1234440"/>
+        </p:xfrm>
+        <a:graphic>
+          <a:graphicData uri="http://schemas.openxmlformats.org/drawingml/2006/table">
+            <a:tbl>
+              <a:tblPr firstRow="1" bandRow="1">
+                <a:tableStyleId>{5C22544A-7EE6-4342-B048-85BDC9FD1C3A}</a:tableStyleId>
+              </a:tblPr>
+              <a:tblGrid>
+                <a:gridCol w="4062046"/>
+                <a:gridCol w="1257300"/>
+                <a:gridCol w="1257300"/>
+                <a:gridCol w="3481753"/>
+              </a:tblGrid>
+              <a:tr h="411480">
+                <a:tc>
+                  <a:txBody>
+                    <a:bodyPr/>
+                    <a:lstStyle/>
+                    <a:p>
+                      <a:pPr algn="l">
+                        <a:defRPr sz="1300" b="1">
+                          <a:solidFill>
+                            <a:srgbClr val="FFFFFF"/>
+                          </a:solidFill>
+                        </a:defRPr>
+                      </a:pPr>
+                      <a:r>
+                        <a:t>Loss function tested</a:t>
+                      </a:r>
+                    </a:p>
+                  </a:txBody>
+                  <a:tcPr marL="73152" marR="73152" marT="27432" marB="27432">
+                    <a:solidFill>
+                      <a:srgbClr val="1F4E79"/>
+                    </a:solidFill>
+                  </a:tcPr>
+                </a:tc>
+                <a:tc>
+                  <a:txBody>
+                    <a:bodyPr/>
+                    <a:lstStyle/>
+                    <a:p>
+                      <a:pPr algn="ctr">
+                        <a:defRPr sz="1300" b="1">
+                          <a:solidFill>
+                            <a:srgbClr val="FFFFFF"/>
+                          </a:solidFill>
+                        </a:defRPr>
+                      </a:pPr>
+                      <a:r>
+                        <a:t>DR F1</a:t>
+                      </a:r>
+                    </a:p>
+                  </a:txBody>
+                  <a:tcPr marL="73152" marR="73152" marT="27432" marB="27432">
+                    <a:solidFill>
+                      <a:srgbClr val="1F4E79"/>
+                    </a:solidFill>
+                  </a:tcPr>
+                </a:tc>
+                <a:tc>
+                  <a:txBody>
+                    <a:bodyPr/>
+                    <a:lstStyle/>
+                    <a:p>
+                      <a:pPr algn="ctr">
+                        <a:defRPr sz="1300" b="1">
+                          <a:solidFill>
+                            <a:srgbClr val="FFFFFF"/>
+                          </a:solidFill>
+                        </a:defRPr>
+                      </a:pPr>
+                      <a:r>
+                        <a:t>ME F1</a:t>
+                      </a:r>
+                    </a:p>
+                  </a:txBody>
+                  <a:tcPr marL="73152" marR="73152" marT="27432" marB="27432">
+                    <a:solidFill>
+                      <a:srgbClr val="1F4E79"/>
+                    </a:solidFill>
+                  </a:tcPr>
+                </a:tc>
+                <a:tc>
+                  <a:txBody>
+                    <a:bodyPr/>
+                    <a:lstStyle/>
+                    <a:p>
+                      <a:pPr algn="ctr">
+                        <a:defRPr sz="1300" b="1">
+                          <a:solidFill>
+                            <a:srgbClr val="FFFFFF"/>
+                          </a:solidFill>
+                        </a:defRPr>
+                      </a:pPr>
+                      <a:r>
+                        <a:t>Outcome</a:t>
+                      </a:r>
+                    </a:p>
+                  </a:txBody>
+                  <a:tcPr marL="73152" marR="73152" marT="27432" marB="27432">
+                    <a:solidFill>
+                      <a:srgbClr val="1F4E79"/>
+                    </a:solidFill>
+                  </a:tcPr>
+                </a:tc>
+              </a:tr>
+              <a:tr h="411480">
+                <a:tc>
+                  <a:txBody>
+                    <a:bodyPr/>
+                    <a:lstStyle/>
+                    <a:p>
+                      <a:pPr algn="l">
+                        <a:defRPr sz="1300">
+                          <a:solidFill>
+                            <a:srgbClr val="1A1A1A"/>
+                          </a:solidFill>
+                        </a:defRPr>
+                      </a:pPr>
+                      <a:r>
+                        <a:t>Focal loss — one dial for all images</a:t>
+                      </a:r>
+                    </a:p>
+                  </a:txBody>
+                  <a:tcPr marL="73152" marR="73152" marT="27432" marB="27432">
+                    <a:solidFill>
+                      <a:srgbClr val="FFFFFF"/>
+                    </a:solidFill>
+                  </a:tcPr>
+                </a:tc>
+                <a:tc>
+                  <a:txBody>
+                    <a:bodyPr/>
+                    <a:lstStyle/>
+                    <a:p>
+                      <a:pPr algn="ctr">
+                        <a:defRPr sz="1300">
+                          <a:solidFill>
+                            <a:srgbClr val="1A1A1A"/>
+                          </a:solidFill>
+                        </a:defRPr>
+                      </a:pPr>
+                      <a:r>
+                        <a:t>0.869</a:t>
+                      </a:r>
+                    </a:p>
+                  </a:txBody>
+                  <a:tcPr marL="73152" marR="73152" marT="27432" marB="27432">
+                    <a:solidFill>
+                      <a:srgbClr val="FFFFFF"/>
+                    </a:solidFill>
+                  </a:tcPr>
+                </a:tc>
+                <a:tc>
+                  <a:txBody>
+                    <a:bodyPr/>
+                    <a:lstStyle/>
+                    <a:p>
+                      <a:pPr algn="ctr">
+                        <a:defRPr sz="1300">
+                          <a:solidFill>
+                            <a:srgbClr val="1A1A1A"/>
+                          </a:solidFill>
+                        </a:defRPr>
+                      </a:pPr>
+                      <a:r>
+                        <a:t>0.748</a:t>
+                      </a:r>
+                    </a:p>
+                  </a:txBody>
+                  <a:tcPr marL="73152" marR="73152" marT="27432" marB="27432">
+                    <a:solidFill>
+                      <a:srgbClr val="FFFFFF"/>
+                    </a:solidFill>
+                  </a:tcPr>
+                </a:tc>
+                <a:tc>
+                  <a:txBody>
+                    <a:bodyPr/>
+                    <a:lstStyle/>
+                    <a:p>
+                      <a:pPr algn="ctr">
+                        <a:defRPr sz="1300">
+                          <a:solidFill>
+                            <a:srgbClr val="1A1A1A"/>
+                          </a:solidFill>
+                        </a:defRPr>
+                      </a:pPr>
+                      <a:r>
+                        <a:t>Kept</a:t>
+                      </a:r>
+                    </a:p>
+                  </a:txBody>
+                  <a:tcPr marL="73152" marR="73152" marT="27432" marB="27432">
+                    <a:solidFill>
+                      <a:srgbClr val="FFFFFF"/>
+                    </a:solidFill>
+                  </a:tcPr>
+                </a:tc>
+              </a:tr>
+              <a:tr h="411480">
+                <a:tc>
+                  <a:txBody>
+                    <a:bodyPr/>
+                    <a:lstStyle/>
+                    <a:p>
+                      <a:pPr algn="l">
+                        <a:defRPr sz="1300">
+                          <a:solidFill>
+                            <a:srgbClr val="1A1A1A"/>
+                          </a:solidFill>
+                        </a:defRPr>
+                      </a:pPr>
+                      <a:r>
+                        <a:t>Asymmetric Loss — separate dials for</a:t>
+                      </a:r>
+                    </a:p>
+                    <a:p>
+                      <a:r>
+                        <a:t>healthy and for diseased images</a:t>
+                      </a:r>
+                    </a:p>
+                  </a:txBody>
+                  <a:tcPr marL="73152" marR="73152" marT="27432" marB="27432">
+                    <a:solidFill>
+                      <a:srgbClr val="F2F4F7"/>
+                    </a:solidFill>
+                  </a:tcPr>
+                </a:tc>
+                <a:tc>
+                  <a:txBody>
+                    <a:bodyPr/>
+                    <a:lstStyle/>
+                    <a:p>
+                      <a:pPr algn="ctr">
+                        <a:defRPr sz="1300">
+                          <a:solidFill>
+                            <a:srgbClr val="1A1A1A"/>
+                          </a:solidFill>
+                        </a:defRPr>
+                      </a:pPr>
+                      <a:r>
+                        <a:t>0.834</a:t>
+                      </a:r>
+                    </a:p>
+                  </a:txBody>
+                  <a:tcPr marL="73152" marR="73152" marT="27432" marB="27432">
+                    <a:solidFill>
+                      <a:srgbClr val="F2F4F7"/>
+                    </a:solidFill>
+                  </a:tcPr>
+                </a:tc>
+                <a:tc>
+                  <a:txBody>
+                    <a:bodyPr/>
+                    <a:lstStyle/>
+                    <a:p>
+                      <a:pPr algn="ctr">
+                        <a:defRPr sz="1300">
+                          <a:solidFill>
+                            <a:srgbClr val="1A1A1A"/>
+                          </a:solidFill>
+                        </a:defRPr>
+                      </a:pPr>
+                      <a:r>
+                        <a:t>0.758</a:t>
+                      </a:r>
+                    </a:p>
+                  </a:txBody>
+                  <a:tcPr marL="73152" marR="73152" marT="27432" marB="27432">
+                    <a:solidFill>
+                      <a:srgbClr val="F2F4F7"/>
+                    </a:solidFill>
+                  </a:tcPr>
+                </a:tc>
+                <a:tc>
+                  <a:txBody>
+                    <a:bodyPr/>
+                    <a:lstStyle/>
+                    <a:p>
+                      <a:pPr algn="ctr">
+                        <a:defRPr sz="1300">
+                          <a:solidFill>
+                            <a:srgbClr val="1A1A1A"/>
+                          </a:solidFill>
+                        </a:defRPr>
+                      </a:pPr>
+                      <a:r>
+                        <a:t>Clearly worse on DR — not used</a:t>
+                      </a:r>
+                    </a:p>
+                  </a:txBody>
+                  <a:tcPr marL="73152" marR="73152" marT="27432" marB="27432">
+                    <a:solidFill>
+                      <a:srgbClr val="F2F4F7"/>
+                    </a:solidFill>
+                  </a:tcPr>
+                </a:tc>
+              </a:tr>
+            </a:tbl>
+          </a:graphicData>
+        </a:graphic>
+      </p:graphicFrame>
+      <p:sp>
+        <p:nvSpPr>
+          <p:cNvPr id="5" name="TextBox 4"/>
           <p:cNvSpPr txBox="1"/>
           <p:nvPr/>
         </p:nvSpPr>
         <p:spPr>
           <a:xfrm>
-            <a:off x="685800" y="4114800"/>
-            <a:ext cx="10881360" cy="2468880"/>
+            <a:off x="685800" y="5806440"/>
+            <a:ext cx="10881360" cy="685800"/>
           </a:xfrm>
           <a:prstGeom prst="rect">
             <a:avLst/>
@@ -6542,62 +6842,14 @@
           <a:lstStyle/>
           <a:p>
             <a:pPr>
-              <a:spcAft>
-                <a:spcPts val="600"/>
-              </a:spcAft>
-              <a:defRPr sz="1600">
+              <a:defRPr sz="1600" b="1">
                 <a:solidFill>
-                  <a:srgbClr val="1A1A1A"/>
+                  <a:srgbClr val="1F4E79"/>
                 </a:solidFill>
               </a:defRPr>
             </a:pPr>
             <a:r>
-              <a:t>• Why we cannot simply tune our way past 0.89:</a:t>
-            </a:r>
-          </a:p>
-          <a:p>
-            <a:pPr lvl="1">
-              <a:spcAft>
-                <a:spcPts val="600"/>
-              </a:spcAft>
-              <a:defRPr sz="1400">
-                <a:solidFill>
-                  <a:srgbClr val="5A5A5A"/>
-                </a:solidFill>
-              </a:defRPr>
-            </a:pPr>
-            <a:r>
-              <a:t>– 162 positive test cases ⇒ bootstrap noise ±0.04 F1; the gap to the paper is 0.021.</a:t>
-            </a:r>
-          </a:p>
-          <a:p>
-            <a:pPr lvl="1">
-              <a:spcAft>
-                <a:spcPts val="600"/>
-              </a:spcAft>
-              <a:defRPr sz="1400">
-                <a:solidFill>
-                  <a:srgbClr val="5A5A5A"/>
-                </a:solidFill>
-              </a:defRPr>
-            </a:pPr>
-            <a:r>
-              <a:t>– Selecting a configuration on test would be test-set overfitting. We select on validation only.</a:t>
-            </a:r>
-          </a:p>
-          <a:p>
-            <a:pPr lvl="1">
-              <a:spcAft>
-                <a:spcPts val="600"/>
-              </a:spcAft>
-              <a:defRPr sz="1400">
-                <a:solidFill>
-                  <a:srgbClr val="5A5A5A"/>
-                </a:solidFill>
-              </a:defRPr>
-            </a:pPr>
-            <a:r>
-              <a:t>– The rigorous fix is k-fold cross-validation — shrinks the interval ~2.2×, making 0.02 measurable.</a:t>
+              <a:t>We tested a more elaborate alternative. It did not help, so the simpler standard loss stands.</a:t>
             </a:r>
           </a:p>
         </p:txBody>

</xml_diff>

<commit_message>
correct the RetiGen figure and cite it on the slide where the claim is made
Slide 10 claimed "published gains on retinal data: +0.085 to +0.121 AUC"
for multi-view aggregation. That number was wrong. Checking RetiGen's actual
results table (arXiv 2403.15647, Table 1, MFIDDR evaluation), the reported
gains across seven baselines are +0.002 to +0.086, median about +0.044 --
not +0.085 to +0.121. The slide overstated the expected benefit by roughly
a factor of two at the low end.

Now states the verified range, names the paper inline where the claim is
made, and adds "achievable, but not guaranteed" -- we need +0.04 and the
weakest reported gain was +0.002, so the method is plausible rather than
assured.

Co-Authored-By: Claude Opus 5 <noreply@anthropic.com>
</commit_message>
<xml_diff>
--- a/presentation/BRSET_ConvNeXtV2_Progress.pptx
+++ b/presentation/BRSET_ConvNeXtV2_Progress.pptx
@@ -3238,8 +3238,8 @@
           <p:nvPr/>
         </p:nvGraphicFramePr>
         <p:xfrm>
-          <a:off x="685800" y="1737360"/>
-          <a:ext cx="10789918" cy="3931920"/>
+          <a:off x="685800" y="1691640"/>
+          <a:ext cx="10789918" cy="4160520"/>
         </p:xfrm>
         <a:graphic>
           <a:graphicData uri="http://schemas.openxmlformats.org/drawingml/2006/table">
@@ -3254,7 +3254,7 @@
                 <a:gridCol w="744132"/>
                 <a:gridCol w="1302231"/>
               </a:tblGrid>
-              <a:tr h="982980">
+              <a:tr h="1040130">
                 <a:tc>
                   <a:txBody>
                     <a:bodyPr/>
@@ -3396,7 +3396,7 @@
                   </a:tcPr>
                 </a:tc>
               </a:tr>
-              <a:tr h="982980">
+              <a:tr h="1040130">
                 <a:tc>
                   <a:txBody>
                     <a:bodyPr/>
@@ -3539,7 +3539,41 @@
                             <a:srgbClr val="1A1A1A"/>
                           </a:solidFill>
                         </a:rPr>
-                        <a:t>Published gains on retinal data: +0.085 to +0.121 AUC. We need +0.04.</a:t>
+                        <a:t>RetiGen (Chen et al., arXiv 2403.15647) does this on fundus images and</a:t>
+                      </a:r>
+                    </a:p>
+                    <a:p>
+                      <a:pPr algn="ctr">
+                        <a:defRPr sz="1150" b="0">
+                          <a:solidFill>
+                            <a:srgbClr val="1A1A1A"/>
+                          </a:solidFill>
+                        </a:defRPr>
+                      </a:pPr>
+                      <a:r>
+                        <a:rPr sz="1150" b="0">
+                          <a:solidFill>
+                            <a:srgbClr val="1A1A1A"/>
+                          </a:solidFill>
+                        </a:rPr>
+                        <a:t>reports +0.002 to +0.086 AUC across seven baselines, median ≈ +0.044.</a:t>
+                      </a:r>
+                    </a:p>
+                    <a:p>
+                      <a:pPr algn="ctr">
+                        <a:defRPr sz="1150" b="0">
+                          <a:solidFill>
+                            <a:srgbClr val="1A1A1A"/>
+                          </a:solidFill>
+                        </a:defRPr>
+                      </a:pPr>
+                      <a:r>
+                        <a:rPr sz="1150" b="0">
+                          <a:solidFill>
+                            <a:srgbClr val="1A1A1A"/>
+                          </a:solidFill>
+                        </a:rPr>
+                        <a:t>We need +0.04 — achievable, but not guaranteed.</a:t>
                       </a:r>
                     </a:p>
                   </a:txBody>
@@ -3606,7 +3640,7 @@
                   </a:tcPr>
                 </a:tc>
               </a:tr>
-              <a:tr h="982980">
+              <a:tr h="1040130">
                 <a:tc>
                   <a:txBody>
                     <a:bodyPr/>
@@ -3816,7 +3850,7 @@
                   </a:tcPr>
                 </a:tc>
               </a:tr>
-              <a:tr h="982980">
+              <a:tr h="1040130">
                 <a:tc>
                   <a:txBody>
                     <a:bodyPr/>
@@ -4055,7 +4089,7 @@
         </p:nvSpPr>
         <p:spPr>
           <a:xfrm>
-            <a:off x="685800" y="5897880"/>
+            <a:off x="685800" y="6035040"/>
             <a:ext cx="10881360" cy="685800"/>
           </a:xfrm>
           <a:prstGeom prst="rect">

</xml_diff>